<commit_message>
Add dashboard slides to CEO presentation and export PDF
- Added 9 new slides: section header, key metrics, 5 dashboard visualizations, CEO recommendations
- Exported updated presentation to PDF via LibreOffice
- Total slides: 33 (was 24)
</commit_message>
<xml_diff>
--- a/CEO_Presentation_PPTX.pptx
+++ b/CEO_Presentation_PPTX.pptx
@@ -28,6 +28,15 @@
     <p:sldId id="276" r:id="rId22"/>
     <p:sldId id="277" r:id="rId23"/>
     <p:sldId id="278" r:id="rId24"/>
+    <p:sldId id="280" r:id="rId30"/>
+    <p:sldId id="281" r:id="rId31"/>
+    <p:sldId id="282" r:id="rId32"/>
+    <p:sldId id="283" r:id="rId33"/>
+    <p:sldId id="284" r:id="rId34"/>
+    <p:sldId id="285" r:id="rId35"/>
+    <p:sldId id="286" r:id="rId36"/>
+    <p:sldId id="288" r:id="rId38"/>
+    <p:sldId id="287" r:id="rId37"/>
     <p:sldId id="279" r:id="rId25"/>
   </p:sldIdLst>
   <p:sldSz cx="9144000" cy="5143500" type="screen16x9"/>
@@ -3253,7 +3262,7 @@
       </p:sp>
       <p:pic>
         <p:nvPicPr>
-          <p:cNvPr descr="CEO_Presentation_PPTX_files/figure-pptx/fig-rep-ranking-1.png" id="0" name="Picture 1"/>
+          <p:cNvPr descr="CEO_Presentation_PPTX_files/figure-pptx/fig-rep-ranking-1.png" id="3" name="Picture 1"/>
           <p:cNvPicPr>
             <a:picLocks noGrp="1" noChangeAspect="1"/>
           </p:cNvPicPr>
@@ -3283,7 +3292,7 @@
       </p:pic>
       <p:sp>
         <p:nvSpPr>
-          <p:cNvPr id="1" name="TextBox 3"/>
+          <p:cNvPr id="4" name="TextBox 3"/>
           <p:cNvSpPr txBox="1"/>
           <p:nvPr>
             <p:ph idx="1"/>
@@ -3496,7 +3505,7 @@
       </p:sp>
       <p:pic>
         <p:nvPicPr>
-          <p:cNvPr descr="CEO_Presentation_PPTX_files/figure-pptx/fig-ian-detail-1.png" id="0" name="Picture 1"/>
+          <p:cNvPr descr="CEO_Presentation_PPTX_files/figure-pptx/fig-ian-detail-1.png" id="3" name="Picture 1"/>
           <p:cNvPicPr>
             <a:picLocks noGrp="1" noChangeAspect="1"/>
           </p:cNvPicPr>
@@ -3526,7 +3535,7 @@
       </p:pic>
       <p:sp>
         <p:nvSpPr>
-          <p:cNvPr id="1" name="TextBox 3"/>
+          <p:cNvPr id="4" name="TextBox 3"/>
           <p:cNvSpPr txBox="1"/>
           <p:nvPr>
             <p:ph idx="1"/>
@@ -3762,7 +3771,7 @@
       </p:sp>
       <p:pic>
         <p:nvPicPr>
-          <p:cNvPr descr="CEO_Presentation_PPTX_files/figure-pptx/fig-peter-detail-1.png" id="0" name="Picture 1"/>
+          <p:cNvPr descr="CEO_Presentation_PPTX_files/figure-pptx/fig-peter-detail-1.png" id="3" name="Picture 1"/>
           <p:cNvPicPr>
             <a:picLocks noGrp="1" noChangeAspect="1"/>
           </p:cNvPicPr>
@@ -3792,7 +3801,7 @@
       </p:pic>
       <p:sp>
         <p:nvSpPr>
-          <p:cNvPr id="1" name="TextBox 3"/>
+          <p:cNvPr id="4" name="TextBox 3"/>
           <p:cNvSpPr txBox="1"/>
           <p:nvPr>
             <p:ph idx="1"/>
@@ -4033,7 +4042,7 @@
       </p:sp>
       <p:pic>
         <p:nvPicPr>
-          <p:cNvPr descr="CEO_Presentation_PPTX_files/figure-pptx/fig-ian-peter-compare-1.png" id="0" name="Picture 1"/>
+          <p:cNvPr descr="CEO_Presentation_PPTX_files/figure-pptx/fig-ian-peter-compare-1.png" id="3" name="Picture 1"/>
           <p:cNvPicPr>
             <a:picLocks noGrp="1" noChangeAspect="1"/>
           </p:cNvPicPr>
@@ -4063,7 +4072,7 @@
       </p:pic>
       <p:sp>
         <p:nvSpPr>
-          <p:cNvPr id="1" name="TextBox 3"/>
+          <p:cNvPr id="4" name="TextBox 3"/>
           <p:cNvSpPr txBox="1"/>
           <p:nvPr>
             <p:ph idx="1"/>
@@ -4142,7 +4151,7 @@
       </p:sp>
       <p:graphicFrame>
         <p:nvGraphicFramePr>
-          <p:cNvPr id="6" name="Content Placeholder 5"/>
+          <p:cNvPr id="3" name="Content Placeholder 5"/>
           <p:cNvGraphicFramePr>
             <a:graphicFrameLocks noGrp="1"/>
           </p:cNvGraphicFramePr>
@@ -4431,7 +4440,7 @@
       </p:grpSpPr>
       <p:sp>
         <p:nvSpPr>
-          <p:cNvPr id="3" name="Content Placeholder 2"/>
+          <p:cNvPr id="2" name="Content Placeholder 2"/>
           <p:cNvSpPr>
             <a:spLocks noGrp="1"/>
           </p:cNvSpPr>
@@ -4621,7 +4630,7 @@
       </p:sp>
       <p:graphicFrame>
         <p:nvGraphicFramePr>
-          <p:cNvPr id="6" name="Content Placeholder 5"/>
+          <p:cNvPr id="3" name="Content Placeholder 5"/>
           <p:cNvGraphicFramePr>
             <a:graphicFrameLocks noGrp="1"/>
           </p:cNvGraphicFramePr>
@@ -4826,7 +4835,7 @@
       </p:sp>
       <p:graphicFrame>
         <p:nvGraphicFramePr>
-          <p:cNvPr id="6" name="Content Placeholder 5"/>
+          <p:cNvPr id="3" name="Content Placeholder 5"/>
           <p:cNvGraphicFramePr>
             <a:graphicFrameLocks noGrp="1"/>
           </p:cNvGraphicFramePr>
@@ -5614,8 +5623,588 @@
           </a:p>
         </p:txBody>
       </p:sp>
+      <p:sp>
+        <p:nvSpPr>
+          <p:cNvPr id="4" name="Title 1"/>
+          <p:cNvSpPr>
+            <a:spLocks noGrp="1"/>
+          </p:cNvSpPr>
+          <p:nvPr>
+            <p:ph type="title"/>
+          </p:nvPr>
+        </p:nvSpPr>
+        <p:spPr>
+          <a:xfrm>
+            <a:off x="457200" y="205979"/>
+            <a:ext cx="8229600" cy="857250"/>
+          </a:xfrm>
+        </p:spPr>
+        <p:txBody>
+          <a:bodyPr/>
+          <a:lstStyle/>
+          <a:p>
+            <a:r>
+              <a:rPr/>
+              <a:t>Interactive Dashboard Highlights</a:t>
+            </a:r>
+          </a:p>
+        </p:txBody>
+      </p:sp>
     </p:spTree>
   </p:cSld>
+</p:sld>
+</file>
+
+<file path=ppt/slides/slide25.xml><?xml version="1.0" encoding="utf-8"?>
+<p:sld xmlns:a="http://schemas.openxmlformats.org/drawingml/2006/main" xmlns:r="http://schemas.openxmlformats.org/officeDocument/2006/relationships" xmlns:p="http://schemas.openxmlformats.org/presentationml/2006/main">
+  <p:cSld>
+    <p:spTree>
+      <p:nvGrpSpPr>
+        <p:cNvPr id="1" name=""/>
+        <p:cNvGrpSpPr/>
+        <p:nvPr/>
+      </p:nvGrpSpPr>
+      <p:grpSpPr>
+        <a:xfrm>
+          <a:off x="0" y="0"/>
+          <a:ext cx="0" cy="0"/>
+          <a:chOff x="0" y="0"/>
+          <a:chExt cx="0" cy="0"/>
+        </a:xfrm>
+      </p:grpSpPr>
+      <p:sp>
+        <p:nvSpPr>
+          <p:cNvPr id="2" name="Title 1"/>
+          <p:cNvSpPr>
+            <a:spLocks noGrp="1"/>
+          </p:cNvSpPr>
+          <p:nvPr>
+            <p:ph type="title"/>
+          </p:nvPr>
+        </p:nvSpPr>
+        <p:spPr>
+          <a:xfrm>
+            <a:off x="722313" y="3305176"/>
+            <a:ext cx="7772400" cy="1021556"/>
+          </a:xfrm>
+        </p:spPr>
+        <p:txBody>
+          <a:bodyPr/>
+          <a:lstStyle/>
+          <a:p>
+            <a:r>
+              <a:rPr/>
+              <a:t>Dashboard Overview — Key Metrics</a:t>
+            </a:r>
+          </a:p>
+        </p:txBody>
+      </p:sp>
+      <p:sp>
+        <p:nvSpPr>
+          <p:cNvPr id="3" name="Text Placeholder 2"/>
+          <p:cNvSpPr>
+            <a:spLocks noGrp="1"/>
+          </p:cNvSpPr>
+          <p:nvPr>
+            <p:ph type="body" idx="1"/>
+          </p:nvPr>
+        </p:nvSpPr>
+        <p:spPr>
+          <a:xfrm>
+            <a:off x="722313" y="2180035"/>
+            <a:ext cx="7772400" cy="1125140"/>
+          </a:xfrm>
+        </p:spPr>
+        <p:txBody>
+          <a:bodyPr/>
+          <a:lstStyle/>
+          <a:p>
+            <a:pPr algn="l" marL="0" marR="0">
+              <a:lnSpc>
+                <a:spcPct val="100000"/>
+              </a:lnSpc>
+              <a:spcBef>
+                <a:spcPts val="0"/>
+              </a:spcBef>
+              <a:spcAft>
+                <a:spcPts val="0"/>
+              </a:spcAft>
+              <a:buNone/>
+            </a:pPr>
+            <a:r>
+              <a:rPr cap="none" sz="1800" i="0" b="1" u="none" strike="noStrike">
+                <a:solidFill>
+                  <a:srgbClr val="2C6E49">
+                    <a:alpha val="100000"/>
+                  </a:srgbClr>
+                </a:solidFill>
+                <a:latin typeface="Arial"/>
+                <a:cs typeface="Arial"/>
+                <a:ea typeface="Arial"/>
+                <a:sym typeface="Arial"/>
+              </a:rPr>
+              <a:t>Total Customers: 1,932</a:t>
+            </a:r>
+          </a:p>
+          <a:p>
+            <a:pPr algn="l" marL="0" marR="0">
+              <a:lnSpc>
+                <a:spcPct val="100000"/>
+              </a:lnSpc>
+              <a:spcBef>
+                <a:spcPts val="0"/>
+              </a:spcBef>
+              <a:spcAft>
+                <a:spcPts val="0"/>
+              </a:spcAft>
+              <a:buNone/>
+            </a:pPr>
+            <a:r>
+              <a:rPr cap="none" sz="1800" i="0" b="1" u="none" strike="noStrike">
+                <a:solidFill>
+                  <a:srgbClr val="2C6E49">
+                    <a:alpha val="100000"/>
+                  </a:srgbClr>
+                </a:solidFill>
+                <a:latin typeface="Arial"/>
+                <a:cs typeface="Arial"/>
+                <a:ea typeface="Arial"/>
+                <a:sym typeface="Arial"/>
+              </a:rPr>
+              <a:t>Total Sales Reps: 30</a:t>
+            </a:r>
+          </a:p>
+          <a:p>
+            <a:pPr algn="l" marL="0" marR="0">
+              <a:lnSpc>
+                <a:spcPct val="100000"/>
+              </a:lnSpc>
+              <a:spcBef>
+                <a:spcPts val="0"/>
+              </a:spcBef>
+              <a:spcAft>
+                <a:spcPts val="0"/>
+              </a:spcAft>
+              <a:buNone/>
+            </a:pPr>
+            <a:r>
+              <a:rPr cap="none" sz="1800" i="0" b="1" u="none" strike="noStrike">
+                <a:solidFill>
+                  <a:srgbClr val="2C6E49">
+                    <a:alpha val="100000"/>
+                  </a:srgbClr>
+                </a:solidFill>
+                <a:latin typeface="Arial"/>
+                <a:cs typeface="Arial"/>
+                <a:ea typeface="Arial"/>
+                <a:sym typeface="Arial"/>
+              </a:rPr>
+              <a:t>Locations Served: 127</a:t>
+            </a:r>
+          </a:p>
+          <a:p>
+            <a:pPr algn="l" marL="0" marR="0">
+              <a:lnSpc>
+                <a:spcPct val="100000"/>
+              </a:lnSpc>
+              <a:spcBef>
+                <a:spcPts val="0"/>
+              </a:spcBef>
+              <a:spcAft>
+                <a:spcPts val="0"/>
+              </a:spcAft>
+              <a:buNone/>
+            </a:pPr>
+            <a:r>
+              <a:rPr cap="none" sz="1800" i="0" b="1" u="none" strike="noStrike">
+                <a:solidFill>
+                  <a:srgbClr val="E67E22">
+                    <a:alpha val="100000"/>
+                  </a:srgbClr>
+                </a:solidFill>
+                <a:latin typeface="Arial"/>
+                <a:cs typeface="Arial"/>
+                <a:ea typeface="Arial"/>
+                <a:sym typeface="Arial"/>
+              </a:rPr>
+              <a:t>Top Rep: Ian (232 customers)</a:t>
+            </a:r>
+          </a:p>
+          <a:p>
+            <a:pPr algn="l" marL="0" marR="0">
+              <a:lnSpc>
+                <a:spcPct val="100000"/>
+              </a:lnSpc>
+              <a:spcBef>
+                <a:spcPts val="0"/>
+              </a:spcBef>
+              <a:spcAft>
+                <a:spcPts val="0"/>
+              </a:spcAft>
+              <a:buNone/>
+            </a:pPr>
+            <a:r>
+              <a:rPr cap="none" sz="1000" i="0" b="0" u="none" strike="noStrike">
+                <a:solidFill>
+                  <a:srgbClr val="000000">
+                    <a:alpha val="100000"/>
+                  </a:srgbClr>
+                </a:solidFill>
+                <a:latin typeface="Arial"/>
+                <a:cs typeface="Arial"/>
+                <a:ea typeface="Arial"/>
+                <a:sym typeface="Arial"/>
+              </a:rPr>
+              <a:t/>
+            </a:r>
+          </a:p>
+          <a:p>
+            <a:pPr algn="l" marL="0" marR="0">
+              <a:lnSpc>
+                <a:spcPct val="100000"/>
+              </a:lnSpc>
+              <a:spcBef>
+                <a:spcPts val="0"/>
+              </a:spcBef>
+              <a:spcAft>
+                <a:spcPts val="0"/>
+              </a:spcAft>
+              <a:buNone/>
+            </a:pPr>
+            <a:r>
+              <a:rPr cap="none" sz="1400" i="1" b="0" u="none" strike="noStrike">
+                <a:solidFill>
+                  <a:srgbClr val="000000">
+                    <a:alpha val="100000"/>
+                  </a:srgbClr>
+                </a:solidFill>
+                <a:latin typeface="Arial"/>
+                <a:cs typeface="Arial"/>
+                <a:ea typeface="Arial"/>
+                <a:sym typeface="Arial"/>
+              </a:rPr>
+              <a:t>The top 5 reps handle 48.6% of all customers.</a:t>
+            </a:r>
+          </a:p>
+        </p:txBody>
+      </p:sp>
+    </p:spTree>
+  </p:cSld>
+  <p:clrMapOvr>
+    <a:masterClrMapping/>
+  </p:clrMapOvr>
+</p:sld>
+</file>
+
+<file path=ppt/slides/slide26.xml><?xml version="1.0" encoding="utf-8"?>
+<p:sld xmlns:a="http://schemas.openxmlformats.org/drawingml/2006/main" xmlns:r="http://schemas.openxmlformats.org/officeDocument/2006/relationships" xmlns:p="http://schemas.openxmlformats.org/presentationml/2006/main">
+  <p:cSld>
+    <p:spTree>
+      <p:nvGrpSpPr>
+        <p:cNvPr id="1" name=""/>
+        <p:cNvGrpSpPr/>
+        <p:nvPr/>
+      </p:nvGrpSpPr>
+      <p:grpSpPr>
+        <a:xfrm>
+          <a:off x="0" y="0"/>
+          <a:ext cx="0" cy="0"/>
+          <a:chOff x="0" y="0"/>
+          <a:chExt cx="0" cy="0"/>
+        </a:xfrm>
+      </p:grpSpPr>
+      <p:sp>
+        <p:nvSpPr>
+          <p:cNvPr id="2" name="Title 1"/>
+          <p:cNvSpPr>
+            <a:spLocks noGrp="1"/>
+          </p:cNvSpPr>
+          <p:nvPr>
+            <p:ph type="title"/>
+          </p:nvPr>
+        </p:nvSpPr>
+        <p:spPr>
+          <a:xfrm>
+            <a:off x="457200" y="205979"/>
+            <a:ext cx="8229600" cy="857250"/>
+          </a:xfrm>
+        </p:spPr>
+        <p:txBody>
+          <a:bodyPr/>
+          <a:lstStyle/>
+          <a:p>
+            <a:r>
+              <a:rPr/>
+              <a:t>Top 15 Sales Reps by Customer Count</a:t>
+            </a:r>
+          </a:p>
+        </p:txBody>
+      </p:sp>
+      <p:pic>
+        <p:nvPicPr>
+          <p:cNvPr id="3" name="" descr=""/>
+          <p:cNvPicPr>
+            <a:picLocks noGrp="1"/>
+          </p:cNvPicPr>
+          <p:nvPr>
+            <p:ph/>
+          </p:nvPr>
+        </p:nvPicPr>
+        <p:blipFill>
+          <a:blip r:embed="rId2"/>
+          <a:stretch>
+            <a:fillRect/>
+          </a:stretch>
+        </p:blipFill>
+        <p:spPr>
+          <a:xfrm>
+            <a:off x="685800" y="1645920"/>
+            <a:ext cx="7772400" cy="4572000"/>
+          </a:xfrm>
+          <a:prstGeom prst="rect">
+            <a:avLst/>
+          </a:prstGeom>
+        </p:spPr>
+      </p:pic>
+    </p:spTree>
+  </p:cSld>
+  <p:clrMapOvr>
+    <a:masterClrMapping/>
+  </p:clrMapOvr>
+</p:sld>
+</file>
+
+<file path=ppt/slides/slide27.xml><?xml version="1.0" encoding="utf-8"?>
+<p:sld xmlns:a="http://schemas.openxmlformats.org/drawingml/2006/main" xmlns:r="http://schemas.openxmlformats.org/officeDocument/2006/relationships" xmlns:p="http://schemas.openxmlformats.org/presentationml/2006/main">
+  <p:cSld>
+    <p:spTree>
+      <p:nvGrpSpPr>
+        <p:cNvPr id="1" name=""/>
+        <p:cNvGrpSpPr/>
+        <p:nvPr/>
+      </p:nvGrpSpPr>
+      <p:grpSpPr>
+        <a:xfrm>
+          <a:off x="0" y="0"/>
+          <a:ext cx="0" cy="0"/>
+          <a:chOff x="0" y="0"/>
+          <a:chExt cx="0" cy="0"/>
+        </a:xfrm>
+      </p:grpSpPr>
+      <p:sp>
+        <p:nvSpPr>
+          <p:cNvPr id="2" name="Title 1"/>
+          <p:cNvSpPr>
+            <a:spLocks noGrp="1"/>
+          </p:cNvSpPr>
+          <p:nvPr>
+            <p:ph type="title"/>
+          </p:nvPr>
+        </p:nvSpPr>
+        <p:spPr>
+          <a:xfrm>
+            <a:off x="457200" y="205979"/>
+            <a:ext cx="8229600" cy="857250"/>
+          </a:xfrm>
+        </p:spPr>
+        <p:txBody>
+          <a:bodyPr/>
+          <a:lstStyle/>
+          <a:p>
+            <a:r>
+              <a:rPr/>
+              <a:t>Top 15 Locations by Customer Count</a:t>
+            </a:r>
+          </a:p>
+        </p:txBody>
+      </p:sp>
+      <p:pic>
+        <p:nvPicPr>
+          <p:cNvPr id="3" name="" descr=""/>
+          <p:cNvPicPr>
+            <a:picLocks noGrp="1"/>
+          </p:cNvPicPr>
+          <p:nvPr>
+            <p:ph/>
+          </p:nvPr>
+        </p:nvPicPr>
+        <p:blipFill>
+          <a:blip r:embed="rId2"/>
+          <a:stretch>
+            <a:fillRect/>
+          </a:stretch>
+        </p:blipFill>
+        <p:spPr>
+          <a:xfrm>
+            <a:off x="685800" y="1645920"/>
+            <a:ext cx="7772400" cy="4572000"/>
+          </a:xfrm>
+          <a:prstGeom prst="rect">
+            <a:avLst/>
+          </a:prstGeom>
+        </p:spPr>
+      </p:pic>
+    </p:spTree>
+  </p:cSld>
+  <p:clrMapOvr>
+    <a:masterClrMapping/>
+  </p:clrMapOvr>
+</p:sld>
+</file>
+
+<file path=ppt/slides/slide28.xml><?xml version="1.0" encoding="utf-8"?>
+<p:sld xmlns:a="http://schemas.openxmlformats.org/drawingml/2006/main" xmlns:r="http://schemas.openxmlformats.org/officeDocument/2006/relationships" xmlns:p="http://schemas.openxmlformats.org/presentationml/2006/main">
+  <p:cSld>
+    <p:spTree>
+      <p:nvGrpSpPr>
+        <p:cNvPr id="1" name=""/>
+        <p:cNvGrpSpPr/>
+        <p:nvPr/>
+      </p:nvGrpSpPr>
+      <p:grpSpPr>
+        <a:xfrm>
+          <a:off x="0" y="0"/>
+          <a:ext cx="0" cy="0"/>
+          <a:chOff x="0" y="0"/>
+          <a:chExt cx="0" cy="0"/>
+        </a:xfrm>
+      </p:grpSpPr>
+      <p:sp>
+        <p:nvSpPr>
+          <p:cNvPr id="2" name="Title 1"/>
+          <p:cNvSpPr>
+            <a:spLocks noGrp="1"/>
+          </p:cNvSpPr>
+          <p:nvPr>
+            <p:ph type="title"/>
+          </p:nvPr>
+        </p:nvSpPr>
+        <p:spPr>
+          <a:xfrm>
+            <a:off x="457200" y="205979"/>
+            <a:ext cx="8229600" cy="857250"/>
+          </a:xfrm>
+        </p:spPr>
+        <p:txBody>
+          <a:bodyPr/>
+          <a:lstStyle/>
+          <a:p>
+            <a:r>
+              <a:rPr/>
+              <a:t>Workload Distribution — All Reps</a:t>
+            </a:r>
+          </a:p>
+        </p:txBody>
+      </p:sp>
+      <p:pic>
+        <p:nvPicPr>
+          <p:cNvPr id="3" name="" descr=""/>
+          <p:cNvPicPr>
+            <a:picLocks noGrp="1"/>
+          </p:cNvPicPr>
+          <p:nvPr>
+            <p:ph/>
+          </p:nvPr>
+        </p:nvPicPr>
+        <p:blipFill>
+          <a:blip r:embed="rId2"/>
+          <a:stretch>
+            <a:fillRect/>
+          </a:stretch>
+        </p:blipFill>
+        <p:spPr>
+          <a:xfrm>
+            <a:off x="685800" y="1645920"/>
+            <a:ext cx="7772400" cy="4572000"/>
+          </a:xfrm>
+          <a:prstGeom prst="rect">
+            <a:avLst/>
+          </a:prstGeom>
+        </p:spPr>
+      </p:pic>
+    </p:spTree>
+  </p:cSld>
+  <p:clrMapOvr>
+    <a:masterClrMapping/>
+  </p:clrMapOvr>
+</p:sld>
+</file>
+
+<file path=ppt/slides/slide29.xml><?xml version="1.0" encoding="utf-8"?>
+<p:sld xmlns:a="http://schemas.openxmlformats.org/drawingml/2006/main" xmlns:r="http://schemas.openxmlformats.org/officeDocument/2006/relationships" xmlns:p="http://schemas.openxmlformats.org/presentationml/2006/main">
+  <p:cSld>
+    <p:spTree>
+      <p:nvGrpSpPr>
+        <p:cNvPr id="1" name=""/>
+        <p:cNvGrpSpPr/>
+        <p:nvPr/>
+      </p:nvGrpSpPr>
+      <p:grpSpPr>
+        <a:xfrm>
+          <a:off x="0" y="0"/>
+          <a:ext cx="0" cy="0"/>
+          <a:chOff x="0" y="0"/>
+          <a:chExt cx="0" cy="0"/>
+        </a:xfrm>
+      </p:grpSpPr>
+      <p:sp>
+        <p:nvSpPr>
+          <p:cNvPr id="2" name="Title 1"/>
+          <p:cNvSpPr>
+            <a:spLocks noGrp="1"/>
+          </p:cNvSpPr>
+          <p:nvPr>
+            <p:ph type="title"/>
+          </p:nvPr>
+        </p:nvSpPr>
+        <p:spPr>
+          <a:xfrm>
+            <a:off x="457200" y="205979"/>
+            <a:ext cx="8229600" cy="857250"/>
+          </a:xfrm>
+        </p:spPr>
+        <p:txBody>
+          <a:bodyPr/>
+          <a:lstStyle/>
+          <a:p>
+            <a:r>
+              <a:rPr/>
+              <a:t>Locations at Risk — Single Rep Coverage</a:t>
+            </a:r>
+          </a:p>
+        </p:txBody>
+      </p:sp>
+      <p:pic>
+        <p:nvPicPr>
+          <p:cNvPr id="3" name="" descr=""/>
+          <p:cNvPicPr>
+            <a:picLocks noGrp="1"/>
+          </p:cNvPicPr>
+          <p:nvPr>
+            <p:ph/>
+          </p:nvPr>
+        </p:nvPicPr>
+        <p:blipFill>
+          <a:blip r:embed="rId2"/>
+          <a:stretch>
+            <a:fillRect/>
+          </a:stretch>
+        </p:blipFill>
+        <p:spPr>
+          <a:xfrm>
+            <a:off x="685800" y="1645920"/>
+            <a:ext cx="7772400" cy="4572000"/>
+          </a:xfrm>
+          <a:prstGeom prst="rect">
+            <a:avLst/>
+          </a:prstGeom>
+        </p:spPr>
+      </p:pic>
+    </p:spTree>
+  </p:cSld>
+  <p:clrMapOvr>
+    <a:masterClrMapping/>
+  </p:clrMapOvr>
 </p:sld>
 </file>
 
@@ -5638,7 +6227,7 @@
       </p:grpSpPr>
       <p:sp>
         <p:nvSpPr>
-          <p:cNvPr id="3" name="Content Placeholder 2"/>
+          <p:cNvPr id="2" name="Content Placeholder 2"/>
           <p:cNvSpPr>
             <a:spLocks noGrp="1"/>
           </p:cNvSpPr>
@@ -5698,6 +6287,471 @@
       </p:sp>
     </p:spTree>
   </p:cSld>
+</p:sld>
+</file>
+
+<file path=ppt/slides/slide30.xml><?xml version="1.0" encoding="utf-8"?>
+<p:sld xmlns:a="http://schemas.openxmlformats.org/drawingml/2006/main" xmlns:r="http://schemas.openxmlformats.org/officeDocument/2006/relationships" xmlns:p="http://schemas.openxmlformats.org/presentationml/2006/main">
+  <p:cSld>
+    <p:spTree>
+      <p:nvGrpSpPr>
+        <p:cNvPr id="1" name=""/>
+        <p:cNvGrpSpPr/>
+        <p:nvPr/>
+      </p:nvGrpSpPr>
+      <p:grpSpPr>
+        <a:xfrm>
+          <a:off x="0" y="0"/>
+          <a:ext cx="0" cy="0"/>
+          <a:chOff x="0" y="0"/>
+          <a:chExt cx="0" cy="0"/>
+        </a:xfrm>
+      </p:grpSpPr>
+      <p:sp>
+        <p:nvSpPr>
+          <p:cNvPr id="2" name="Title 1"/>
+          <p:cNvSpPr>
+            <a:spLocks noGrp="1"/>
+          </p:cNvSpPr>
+          <p:nvPr>
+            <p:ph type="title"/>
+          </p:nvPr>
+        </p:nvSpPr>
+        <p:spPr>
+          <a:xfrm>
+            <a:off x="457200" y="205979"/>
+            <a:ext cx="8229600" cy="857250"/>
+          </a:xfrm>
+        </p:spPr>
+        <p:txBody>
+          <a:bodyPr/>
+          <a:lstStyle/>
+          <a:p>
+            <a:r>
+              <a:rPr/>
+              <a:t>Rep × Location Heatmap (Top 10 × 10)</a:t>
+            </a:r>
+          </a:p>
+        </p:txBody>
+      </p:sp>
+      <p:pic>
+        <p:nvPicPr>
+          <p:cNvPr id="3" name="" descr=""/>
+          <p:cNvPicPr>
+            <a:picLocks noGrp="1"/>
+          </p:cNvPicPr>
+          <p:nvPr>
+            <p:ph/>
+          </p:nvPr>
+        </p:nvPicPr>
+        <p:blipFill>
+          <a:blip r:embed="rId2"/>
+          <a:stretch>
+            <a:fillRect/>
+          </a:stretch>
+        </p:blipFill>
+        <p:spPr>
+          <a:xfrm>
+            <a:off x="685800" y="1645920"/>
+            <a:ext cx="7772400" cy="4572000"/>
+          </a:xfrm>
+          <a:prstGeom prst="rect">
+            <a:avLst/>
+          </a:prstGeom>
+        </p:spPr>
+      </p:pic>
+    </p:spTree>
+  </p:cSld>
+  <p:clrMapOvr>
+    <a:masterClrMapping/>
+  </p:clrMapOvr>
+</p:sld>
+</file>
+
+<file path=ppt/slides/slide31.xml><?xml version="1.0" encoding="utf-8"?>
+<p:sld xmlns:a="http://schemas.openxmlformats.org/drawingml/2006/main" xmlns:r="http://schemas.openxmlformats.org/officeDocument/2006/relationships" xmlns:p="http://schemas.openxmlformats.org/presentationml/2006/main">
+  <p:cSld>
+    <p:spTree>
+      <p:nvGrpSpPr>
+        <p:cNvPr id="1" name=""/>
+        <p:cNvGrpSpPr/>
+        <p:nvPr/>
+      </p:nvGrpSpPr>
+      <p:grpSpPr>
+        <a:xfrm>
+          <a:off x="0" y="0"/>
+          <a:ext cx="0" cy="0"/>
+          <a:chOff x="0" y="0"/>
+          <a:chExt cx="0" cy="0"/>
+        </a:xfrm>
+      </p:grpSpPr>
+      <p:sp>
+        <p:nvSpPr>
+          <p:cNvPr id="2" name="Title 1"/>
+          <p:cNvSpPr>
+            <a:spLocks noGrp="1"/>
+          </p:cNvSpPr>
+          <p:nvPr>
+            <p:ph type="title"/>
+          </p:nvPr>
+        </p:nvSpPr>
+        <p:spPr>
+          <a:xfrm>
+            <a:off x="457200" y="205979"/>
+            <a:ext cx="8229600" cy="857250"/>
+          </a:xfrm>
+        </p:spPr>
+        <p:txBody>
+          <a:bodyPr/>
+          <a:lstStyle/>
+          <a:p>
+            <a:r>
+              <a:rPr/>
+              <a:t>CEO Recommendations</a:t>
+            </a:r>
+          </a:p>
+        </p:txBody>
+      </p:sp>
+      <p:sp>
+        <p:nvSpPr>
+          <p:cNvPr id="3" name="Title 1"/>
+          <p:cNvSpPr>
+            <a:spLocks noGrp="1"/>
+          </p:cNvSpPr>
+          <p:nvPr>
+            <p:ph type="title"/>
+          </p:nvPr>
+        </p:nvSpPr>
+        <p:spPr>
+          <a:xfrm>
+            <a:off x="457200" y="205979"/>
+            <a:ext cx="8229600" cy="857250"/>
+          </a:xfrm>
+        </p:spPr>
+        <p:txBody>
+          <a:bodyPr/>
+          <a:lstStyle/>
+          <a:p>
+            <a:r>
+              <a:rPr/>
+              <a:t>CEO Recommendations</a:t>
+            </a:r>
+          </a:p>
+        </p:txBody>
+      </p:sp>
+    </p:spTree>
+  </p:cSld>
+  <p:clrMapOvr>
+    <a:masterClrMapping/>
+  </p:clrMapOvr>
+</p:sld>
+</file>
+
+<file path=ppt/slides/slide32.xml><?xml version="1.0" encoding="utf-8"?>
+<p:sld xmlns:a="http://schemas.openxmlformats.org/drawingml/2006/main" xmlns:r="http://schemas.openxmlformats.org/officeDocument/2006/relationships" xmlns:p="http://schemas.openxmlformats.org/presentationml/2006/main">
+  <p:cSld>
+    <p:spTree>
+      <p:nvGrpSpPr>
+        <p:cNvPr id="1" name=""/>
+        <p:cNvGrpSpPr/>
+        <p:nvPr/>
+      </p:nvGrpSpPr>
+      <p:grpSpPr>
+        <a:xfrm>
+          <a:off x="0" y="0"/>
+          <a:ext cx="0" cy="0"/>
+          <a:chOff x="0" y="0"/>
+          <a:chExt cx="0" cy="0"/>
+        </a:xfrm>
+      </p:grpSpPr>
+    </p:spTree>
+  </p:cSld>
+  <p:clrMapOvr>
+    <a:masterClrMapping/>
+  </p:clrMapOvr>
+</p:sld>
+</file>
+
+<file path=ppt/slides/slide33.xml><?xml version="1.0" encoding="utf-8"?>
+<p:sld xmlns:a="http://schemas.openxmlformats.org/drawingml/2006/main" xmlns:r="http://schemas.openxmlformats.org/officeDocument/2006/relationships" xmlns:p="http://schemas.openxmlformats.org/presentationml/2006/main">
+  <p:cSld>
+    <p:spTree>
+      <p:nvGrpSpPr>
+        <p:cNvPr id="1" name=""/>
+        <p:cNvGrpSpPr/>
+        <p:nvPr/>
+      </p:nvGrpSpPr>
+      <p:grpSpPr>
+        <a:xfrm>
+          <a:off x="0" y="0"/>
+          <a:ext cx="0" cy="0"/>
+          <a:chOff x="0" y="0"/>
+          <a:chExt cx="0" cy="0"/>
+        </a:xfrm>
+      </p:grpSpPr>
+      <p:sp>
+        <p:nvSpPr>
+          <p:cNvPr id="2" name="Title 1"/>
+          <p:cNvSpPr>
+            <a:spLocks noGrp="1"/>
+          </p:cNvSpPr>
+          <p:nvPr>
+            <p:ph type="title"/>
+          </p:nvPr>
+        </p:nvSpPr>
+        <p:spPr>
+          <a:xfrm>
+            <a:off x="457200" y="205979"/>
+            <a:ext cx="8229600" cy="857250"/>
+          </a:xfrm>
+        </p:spPr>
+        <p:txBody>
+          <a:bodyPr/>
+          <a:lstStyle/>
+          <a:p>
+            <a:r>
+              <a:rPr/>
+              <a:t>CEO Recommendations</a:t>
+            </a:r>
+          </a:p>
+        </p:txBody>
+      </p:sp>
+      <p:sp>
+        <p:nvSpPr>
+          <p:cNvPr id="3" name="Content Placeholder 2"/>
+          <p:cNvSpPr>
+            <a:spLocks noGrp="1"/>
+          </p:cNvSpPr>
+          <p:nvPr>
+            <p:ph idx="1"/>
+          </p:nvPr>
+        </p:nvSpPr>
+        <p:spPr>
+          <a:xfrm>
+            <a:off x="457200" y="1200151"/>
+            <a:ext cx="8229600" cy="3394472"/>
+          </a:xfrm>
+        </p:spPr>
+        <p:txBody>
+          <a:bodyPr/>
+          <a:lstStyle/>
+          <a:p>
+            <a:pPr algn="l" marL="0" marR="0">
+              <a:lnSpc>
+                <a:spcPct val="100000"/>
+              </a:lnSpc>
+              <a:spcBef>
+                <a:spcPts val="0"/>
+              </a:spcBef>
+              <a:spcAft>
+                <a:spcPts val="0"/>
+              </a:spcAft>
+              <a:buNone/>
+            </a:pPr>
+            <a:r>
+              <a:rPr cap="none" sz="1400" i="0" b="1" u="none" strike="noStrike">
+                <a:solidFill>
+                  <a:srgbClr val="2C6E49">
+                    <a:alpha val="100000"/>
+                  </a:srgbClr>
+                </a:solidFill>
+                <a:latin typeface="Arial"/>
+                <a:cs typeface="Arial"/>
+                <a:ea typeface="Arial"/>
+                <a:sym typeface="Arial"/>
+              </a:rPr>
+              <a:t>1. Rebalance territories — </a:t>
+            </a:r>
+            <a:r>
+              <a:rPr cap="none" sz="1300" i="0" b="0" u="none" strike="noStrike">
+                <a:solidFill>
+                  <a:srgbClr val="000000">
+                    <a:alpha val="100000"/>
+                  </a:srgbClr>
+                </a:solidFill>
+                <a:latin typeface="Arial"/>
+                <a:cs typeface="Arial"/>
+                <a:ea typeface="Arial"/>
+                <a:sym typeface="Arial"/>
+              </a:rPr>
+              <a:t>Redistribute customers from overloaded reps to underutilized ones. Target max ~120 per rep.</a:t>
+            </a:r>
+          </a:p>
+          <a:p>
+            <a:pPr algn="l" marL="0" marR="0">
+              <a:lnSpc>
+                <a:spcPct val="100000"/>
+              </a:lnSpc>
+              <a:spcBef>
+                <a:spcPts val="0"/>
+              </a:spcBef>
+              <a:spcAft>
+                <a:spcPts val="0"/>
+              </a:spcAft>
+              <a:buNone/>
+            </a:pPr>
+            <a:r>
+              <a:rPr cap="none" sz="1400" i="0" b="1" u="none" strike="noStrike">
+                <a:solidFill>
+                  <a:srgbClr val="2C6E49">
+                    <a:alpha val="100000"/>
+                  </a:srgbClr>
+                </a:solidFill>
+                <a:latin typeface="Arial"/>
+                <a:cs typeface="Arial"/>
+                <a:ea typeface="Arial"/>
+                <a:sym typeface="Arial"/>
+              </a:rPr>
+              <a:t>2. Formalize territory mapping — </a:t>
+            </a:r>
+            <a:r>
+              <a:rPr cap="none" sz="1300" i="0" b="0" u="none" strike="noStrike">
+                <a:solidFill>
+                  <a:srgbClr val="000000">
+                    <a:alpha val="100000"/>
+                  </a:srgbClr>
+                </a:solidFill>
+                <a:latin typeface="Arial"/>
+                <a:cs typeface="Arial"/>
+                <a:ea typeface="Arial"/>
+                <a:sym typeface="Arial"/>
+              </a:rPr>
+              <a:t>Assign each location a primary and backup rep to eliminate overlap and ensure continuity.</a:t>
+            </a:r>
+          </a:p>
+          <a:p>
+            <a:pPr algn="l" marL="0" marR="0">
+              <a:lnSpc>
+                <a:spcPct val="100000"/>
+              </a:lnSpc>
+              <a:spcBef>
+                <a:spcPts val="0"/>
+              </a:spcBef>
+              <a:spcAft>
+                <a:spcPts val="0"/>
+              </a:spcAft>
+              <a:buNone/>
+            </a:pPr>
+            <a:r>
+              <a:rPr cap="none" sz="1400" i="0" b="1" u="none" strike="noStrike">
+                <a:solidFill>
+                  <a:srgbClr val="2C6E49">
+                    <a:alpha val="100000"/>
+                  </a:srgbClr>
+                </a:solidFill>
+                <a:latin typeface="Arial"/>
+                <a:cs typeface="Arial"/>
+                <a:ea typeface="Arial"/>
+                <a:sym typeface="Arial"/>
+              </a:rPr>
+              <a:t>3. Audit low-activity reps — </a:t>
+            </a:r>
+            <a:r>
+              <a:rPr cap="none" sz="1300" i="0" b="0" u="none" strike="noStrike">
+                <a:solidFill>
+                  <a:srgbClr val="000000">
+                    <a:alpha val="100000"/>
+                  </a:srgbClr>
+                </a:solidFill>
+                <a:latin typeface="Arial"/>
+                <a:cs typeface="Arial"/>
+                <a:ea typeface="Arial"/>
+                <a:sym typeface="Arial"/>
+              </a:rPr>
+              <a:t>8 reps have 5 or fewer customers. Review for reassignment or retraining.</a:t>
+            </a:r>
+          </a:p>
+          <a:p>
+            <a:pPr algn="l" marL="0" marR="0">
+              <a:lnSpc>
+                <a:spcPct val="100000"/>
+              </a:lnSpc>
+              <a:spcBef>
+                <a:spcPts val="0"/>
+              </a:spcBef>
+              <a:spcAft>
+                <a:spcPts val="0"/>
+              </a:spcAft>
+              <a:buNone/>
+            </a:pPr>
+            <a:r>
+              <a:rPr cap="none" sz="1400" i="0" b="1" u="none" strike="noStrike">
+                <a:solidFill>
+                  <a:srgbClr val="2C6E49">
+                    <a:alpha val="100000"/>
+                  </a:srgbClr>
+                </a:solidFill>
+                <a:latin typeface="Arial"/>
+                <a:cs typeface="Arial"/>
+                <a:ea typeface="Arial"/>
+                <a:sym typeface="Arial"/>
+              </a:rPr>
+              <a:t>4. Diversify geographic reach — </a:t>
+            </a:r>
+            <a:r>
+              <a:rPr cap="none" sz="1300" i="0" b="0" u="none" strike="noStrike">
+                <a:solidFill>
+                  <a:srgbClr val="000000">
+                    <a:alpha val="100000"/>
+                  </a:srgbClr>
+                </a:solidFill>
+                <a:latin typeface="Arial"/>
+                <a:cs typeface="Arial"/>
+                <a:ea typeface="Arial"/>
+                <a:sym typeface="Arial"/>
+              </a:rPr>
+              <a:t>Develop growth plans beyond the Ibadan-Ogun-Lagos corridor to reduce concentration risk.</a:t>
+            </a:r>
+          </a:p>
+          <a:p>
+            <a:pPr algn="l" marL="0" marR="0">
+              <a:lnSpc>
+                <a:spcPct val="100000"/>
+              </a:lnSpc>
+              <a:spcBef>
+                <a:spcPts val="0"/>
+              </a:spcBef>
+              <a:spcAft>
+                <a:spcPts val="0"/>
+              </a:spcAft>
+              <a:buNone/>
+            </a:pPr>
+            <a:r>
+              <a:rPr cap="none" sz="1400" i="0" b="1" u="none" strike="noStrike">
+                <a:solidFill>
+                  <a:srgbClr val="2C6E49">
+                    <a:alpha val="100000"/>
+                  </a:srgbClr>
+                </a:solidFill>
+                <a:latin typeface="Arial"/>
+                <a:cs typeface="Arial"/>
+                <a:ea typeface="Arial"/>
+                <a:sym typeface="Arial"/>
+              </a:rPr>
+              <a:t>5. Add performance data — </a:t>
+            </a:r>
+            <a:r>
+              <a:rPr cap="none" sz="1300" i="0" b="0" u="none" strike="noStrike">
+                <a:solidFill>
+                  <a:srgbClr val="000000">
+                    <a:alpha val="100000"/>
+                  </a:srgbClr>
+                </a:solidFill>
+                <a:latin typeface="Arial"/>
+                <a:cs typeface="Arial"/>
+                <a:ea typeface="Arial"/>
+                <a:sym typeface="Arial"/>
+              </a:rPr>
+              <a:t>Integrate revenue and visit-frequency data to move from headcount to value-based territory management.</a:t>
+            </a:r>
+          </a:p>
+        </p:txBody>
+      </p:sp>
+    </p:spTree>
+  </p:cSld>
+  <p:clrMapOvr>
+    <a:masterClrMapping/>
+  </p:clrMapOvr>
 </p:sld>
 </file>
 
@@ -6034,7 +7088,7 @@
       </p:sp>
       <p:graphicFrame>
         <p:nvGraphicFramePr>
-          <p:cNvPr id="6" name="Content Placeholder 5"/>
+          <p:cNvPr id="3" name="Content Placeholder 5"/>
           <p:cNvGraphicFramePr>
             <a:graphicFrameLocks noGrp="1"/>
           </p:cNvGraphicFramePr>
@@ -6417,7 +7471,7 @@
       </p:grpSpPr>
       <p:sp>
         <p:nvSpPr>
-          <p:cNvPr id="3" name="Content Placeholder 2"/>
+          <p:cNvPr id="2" name="Content Placeholder 2"/>
           <p:cNvSpPr>
             <a:spLocks noGrp="1"/>
           </p:cNvSpPr>
@@ -6493,7 +7547,7 @@
       </p:sp>
       <p:pic>
         <p:nvPicPr>
-          <p:cNvPr descr="CEO_Presentation_PPTX_files/figure-pptx/fig-location-dist-1.png" id="0" name="Picture 1"/>
+          <p:cNvPr descr="CEO_Presentation_PPTX_files/figure-pptx/fig-location-dist-1.png" id="3" name="Picture 1"/>
           <p:cNvPicPr>
             <a:picLocks noGrp="1" noChangeAspect="1"/>
           </p:cNvPicPr>
@@ -6523,7 +7577,7 @@
       </p:pic>
       <p:sp>
         <p:nvSpPr>
-          <p:cNvPr id="1" name="TextBox 3"/>
+          <p:cNvPr id="4" name="TextBox 3"/>
           <p:cNvSpPr txBox="1"/>
           <p:nvPr>
             <p:ph idx="1"/>

</xml_diff>